<commit_message>
docs(presentation): revise the eight-slide deck to the delivered service
The 24.10 deck described the target concept. Revision 29.10 keeps the
story and layout and changes what is now known: the cover names a
closed technical pilot, slide 4 says access logs instead of traces,
slides 6-8 and the notes state what is verified locally and in CI,
what is not, the HTTP/Python profile and the disabled model, and that
pilot terms are a proposal.

src/revise_2026_10_29.py applies the edits to the 24.10 PPTX and
writes notes from slides.json; export_pdf.ps1 renders PDF and slide
previews from the same PPTX with PowerPoint. All eight slides checked.

Co-Authored-By: Claude Opus 5.5 <noreply@anthropic.com>
</commit_message>
<xml_diff>
--- a/docs/product/pilot/presentation/pilot-presentation.pptx
+++ b/docs/product/pilot/presentation/pilot-presentation.pptx
@@ -449,22 +449,7 @@
           <a:lstStyle xmlns:a="http://schemas.openxmlformats.org/drawingml/2006/main"/>
           <a:p xmlns:a="http://schemas.openxmlformats.org/drawingml/2006/main">
             <a:r>
-              <a:t>Целевой автономный B2B-сервис. Помогает команде заранее увидеть возможное влияние изменения на соседние команды. Полный автономный сценарий ещё не реализован; экономия и спрос не измерены.</a:t>
-            </a:r>
-          </a:p>
-          <a:p xmlns:a="http://schemas.openxmlformats.org/drawingml/2006/main">
-            <a:r>
-              <a:t/>
-            </a:r>
-          </a:p>
-          <a:p xmlns:a="http://schemas.openxmlformats.org/drawingml/2006/main">
-            <a:r>
-              <a:t>Источники:</a:t>
-            </a:r>
-          </a:p>
-          <a:p xmlns:a="http://schemas.openxmlformats.org/drawingml/2006/main">
-            <a:r>
-              <a:t>docs/product/pilot/OFFER.md</a:t>
+              <a:t>Сервис для команд, которые меняют внутренние HTTP API. Предлагаем закрытый технический пилот на поддерживаемом профиле HTTP/Python. Модель выключена. Спрос, экономия и польза для команды не измерены.</a:t>
             </a:r>
           </a:p>
         </p:txBody>
@@ -537,26 +522,6 @@
               <a:t>Иллюстрация: задача предлагает ограничить выдачу заказов. Граф связывает потребителя с операцией и основанием. Статическая связь и наблюдение вызова помогают выбрать проверку, но не доказывают будущую поломку. Пример не является клиентским кейсом.</a:t>
             </a:r>
           </a:p>
-          <a:p xmlns:a="http://schemas.openxmlformats.org/drawingml/2006/main">
-            <a:r>
-              <a:t/>
-            </a:r>
-          </a:p>
-          <a:p xmlns:a="http://schemas.openxmlformats.org/drawingml/2006/main">
-            <a:r>
-              <a:t>Источники:</a:t>
-            </a:r>
-          </a:p>
-          <a:p xmlns:a="http://schemas.openxmlformats.org/drawingml/2006/main">
-            <a:r>
-              <a:t>docs/product/pilot/GRAPH.md</a:t>
-            </a:r>
-          </a:p>
-          <a:p xmlns:a="http://schemas.openxmlformats.org/drawingml/2006/main">
-            <a:r>
-              <a:t>docs/agent-graph-demo/deployments/2026-10-22/README.md</a:t>
-            </a:r>
-          </a:p>
         </p:txBody>
       </p:sp>
       <p:sp>
@@ -624,27 +589,7 @@
           <a:lstStyle xmlns:a="http://schemas.openxmlformats.org/drawingml/2006/main"/>
           <a:p xmlns:a="http://schemas.openxmlformats.org/drawingml/2006/main">
             <a:r>
-              <a:t>Два входа в общий анализ. Jira работает с намерением и даёт предварительную область влияния. PR работает с diff по двум SHA и уточняет конкретные места. Оба результата — план первого автономного выпуска. Один комментарий обновляется; не нужен оператор на каждую задачу.</a:t>
-            </a:r>
-          </a:p>
-          <a:p xmlns:a="http://schemas.openxmlformats.org/drawingml/2006/main">
-            <a:r>
-              <a:t/>
-            </a:r>
-          </a:p>
-          <a:p xmlns:a="http://schemas.openxmlformats.org/drawingml/2006/main">
-            <a:r>
-              <a:t>Источники:</a:t>
-            </a:r>
-          </a:p>
-          <a:p xmlns:a="http://schemas.openxmlformats.org/drawingml/2006/main">
-            <a:r>
-              <a:t>docs/product/pilot/OFFER.md</a:t>
-            </a:r>
-          </a:p>
-          <a:p xmlns:a="http://schemas.openxmlformats.org/drawingml/2006/main">
-            <a:r>
-              <a:t>docs/product/pilot/DECISIONS.md</a:t>
+              <a:t>Два входа в один анализ. Задача Jira даёт предварительную область влияния до кода. PR уточняет её по diff двух коммитов. Оба пути реализованы и проверены локально и в CI; на настоящих GitHub и Jira ещё не запускались. Один комментарий обновляется при каждом изменении, оператор на задачу не нужен.</a:t>
             </a:r>
           </a:p>
         </p:txBody>
@@ -714,27 +659,7 @@
           <a:lstStyle xmlns:a="http://schemas.openxmlformats.org/drawingml/2006/main"/>
           <a:p xmlns:a="http://schemas.openxmlformats.org/drawingml/2006/main">
             <a:r>
-              <a:t>Граф — обновляемая память с основаниями: кто вызывает кого, по какому источнику и когда это актуально. Код даёт объявленные вызовы; трассы или подходящие логи — наблюдения. Агент использует карту при анализе; человек может открыть путь и источник. Статическая находка, runtime-наблюдение и модельная гипотеза раздельны. Runtime-коннектор и устойчивый граф пока план.</a:t>
-            </a:r>
-          </a:p>
-          <a:p xmlns:a="http://schemas.openxmlformats.org/drawingml/2006/main">
-            <a:r>
-              <a:t/>
-            </a:r>
-          </a:p>
-          <a:p xmlns:a="http://schemas.openxmlformats.org/drawingml/2006/main">
-            <a:r>
-              <a:t>Источники:</a:t>
-            </a:r>
-          </a:p>
-          <a:p xmlns:a="http://schemas.openxmlformats.org/drawingml/2006/main">
-            <a:r>
-              <a:t>docs/product/pilot/GRAPH.md</a:t>
-            </a:r>
-          </a:p>
-          <a:p xmlns:a="http://schemas.openxmlformats.org/drawingml/2006/main">
-            <a:r>
-              <a:t>https://grafana.com/docs/tempo/latest/metrics-from-traces/service_graphs/</a:t>
+              <a:t>Граф хранит связи с основаниями: источник, версия или окно наблюдения, свежесть. Код даёт объявленные вызовы в профиле HTTP/Python. Структурированные журналы доступа дают наблюдения; трассы пока не подключаются. Статическая находка, наблюдение и гипотеза показываются раздельно.</a:t>
             </a:r>
           </a:p>
         </p:txBody>
@@ -807,41 +732,6 @@
               <a:t>Сравнение задач по официальным источникам от 24.10.2026; общий эксперимент качества не проводился. Qwen-Agent поддерживает инструменты и MCP. Sourcegraph умеет точную навигацию SCIP. oasdiff сравнивает OpenAPI, Pact проверяет контракты. Tempo строит граф из трасс. Не утверждаем, что у альтернатив нет проверяемых оснований. Гипотеза сервиса — общий актуальный контекст кода и runtime для раннего Jira/PR-инсайта.</a:t>
             </a:r>
           </a:p>
-          <a:p xmlns:a="http://schemas.openxmlformats.org/drawingml/2006/main">
-            <a:r>
-              <a:t/>
-            </a:r>
-          </a:p>
-          <a:p xmlns:a="http://schemas.openxmlformats.org/drawingml/2006/main">
-            <a:r>
-              <a:t>Источники:</a:t>
-            </a:r>
-          </a:p>
-          <a:p xmlns:a="http://schemas.openxmlformats.org/drawingml/2006/main">
-            <a:r>
-              <a:t>https://github.com/QwenLM/Qwen-Agent</a:t>
-            </a:r>
-          </a:p>
-          <a:p xmlns:a="http://schemas.openxmlformats.org/drawingml/2006/main">
-            <a:r>
-              <a:t>https://sourcegraph.com/docs/code-navigation/precise-code-navigation</a:t>
-            </a:r>
-          </a:p>
-          <a:p xmlns:a="http://schemas.openxmlformats.org/drawingml/2006/main">
-            <a:r>
-              <a:t>https://www.oasdiff.com/docs/getting-started</a:t>
-            </a:r>
-          </a:p>
-          <a:p xmlns:a="http://schemas.openxmlformats.org/drawingml/2006/main">
-            <a:r>
-              <a:t>https://docs.pact.io/</a:t>
-            </a:r>
-          </a:p>
-          <a:p xmlns:a="http://schemas.openxmlformats.org/drawingml/2006/main">
-            <a:r>
-              <a:t>https://grafana.com/docs/tempo/latest/metrics-from-traces/service_graphs/</a:t>
-            </a:r>
-          </a:p>
         </p:txBody>
       </p:sp>
       <p:sp>
@@ -909,32 +799,7 @@
           <a:lstStyle xmlns:a="http://schemas.openxmlformats.org/drawingml/2006/main"/>
           <a:p xmlns:a="http://schemas.openxmlformats.org/drawingml/2006/main">
             <a:r>
-              <a:t>Целевая установка: закреплённый релиз на Linux-ВМ; Cloud.ru — адаптер создания ВМ с тем же installer. Владелец один раз задаёт доступы и рамки ресурсов. Модель может использовать внутренний либо отдельно согласованный внешний endpoint. Конституция исполняется инструментами, схемами, правами и лимитами. Повторная установка, восстановление и возврат обязательны, но пока не проверены для автономного сервиса.</a:t>
-            </a:r>
-          </a:p>
-          <a:p xmlns:a="http://schemas.openxmlformats.org/drawingml/2006/main">
-            <a:r>
-              <a:t/>
-            </a:r>
-          </a:p>
-          <a:p xmlns:a="http://schemas.openxmlformats.org/drawingml/2006/main">
-            <a:r>
-              <a:t>Источники:</a:t>
-            </a:r>
-          </a:p>
-          <a:p xmlns:a="http://schemas.openxmlformats.org/drawingml/2006/main">
-            <a:r>
-              <a:t>docs/product/pilot/INSTALLATION.md</a:t>
-            </a:r>
-          </a:p>
-          <a:p xmlns:a="http://schemas.openxmlformats.org/drawingml/2006/main">
-            <a:r>
-              <a:t>docs/product/pilot/CONSTITUTION.md</a:t>
-            </a:r>
-          </a:p>
-          <a:p xmlns:a="http://schemas.openxmlformats.org/drawingml/2006/main">
-            <a:r>
-              <a:t>https://cloud.ru/docs/terraform-evolution/ug/topics/quickstart</a:t>
+              <a:t>Релиз ставится на Linux-ВМ через systemd. Установка, обновление и откат проверены на CI-раннере, на целевой ВМ Cloud.ru ещё нет. Владелец один раз подключает GitHub App, при желании Jira, и репозитории. Модель выключена, анализ детерминированный. Секреты хранятся вне Git.</a:t>
             </a:r>
           </a:p>
         </p:txBody>
@@ -1004,32 +869,7 @@
           <a:lstStyle xmlns:a="http://schemas.openxmlformats.org/drawingml/2006/main"/>
           <a:p xmlns:a="http://schemas.openxmlformats.org/drawingml/2006/main">
             <a:r>
-              <a:t>Сейчас узкое статическое ядро requests/FastAPI/OpenAPI JSON, digest и строки, история контекстов, синтетическое демо. PR45/46 слиты. Пока нет автономных Jira/PR, runtime-коннектора, устойчивого графа и проверенной коробки нового сервиса. Qwen 0/3 в серии остановился на invalid_model_action до семантики, поэтому сначала диагностика/согласование протокола, затем квалификация. Не обещать готовность модели или срок из старого ручного пилота.</a:t>
-            </a:r>
-          </a:p>
-          <a:p xmlns:a="http://schemas.openxmlformats.org/drawingml/2006/main">
-            <a:r>
-              <a:t/>
-            </a:r>
-          </a:p>
-          <a:p xmlns:a="http://schemas.openxmlformats.org/drawingml/2006/main">
-            <a:r>
-              <a:t>Источники:</a:t>
-            </a:r>
-          </a:p>
-          <a:p xmlns:a="http://schemas.openxmlformats.org/drawingml/2006/main">
-            <a:r>
-              <a:t>docs/product/pilot/EVIDENCE.md</a:t>
-            </a:r>
-          </a:p>
-          <a:p xmlns:a="http://schemas.openxmlformats.org/drawingml/2006/main">
-            <a:r>
-              <a:t>docs/product/pilot/BACKLOG.md</a:t>
-            </a:r>
-          </a:p>
-          <a:p xmlns:a="http://schemas.openxmlformats.org/drawingml/2006/main">
-            <a:r>
-              <a:t>experiments/evidence_refs_v2/runs/2026-10-22-batch1/README.md</a:t>
+              <a:t>Проверено локально и в CI: webhook Jira и PR, один обновляемый комментарий, основания вида репозиторий@коммит:строка, установка и откат релиза, локальный показ изменение, исправление, нейтральный контроль. Не проверено: настоящие App и Jira, установка на целевой ВМ, незнакомый проект и польза. Модель не прошла транспортный допуск и выключена.</a:t>
             </a:r>
           </a:p>
         </p:txBody>
@@ -1099,32 +939,7 @@
           <a:lstStyle xmlns:a="http://schemas.openxmlformats.org/drawingml/2006/main"/>
           <a:p xmlns:a="http://schemas.openxmlformats.org/drawingml/2006/main">
             <a:r>
-              <a:t>После инженерной готовности выбрать один API и связанные потребители, доступный runtime-источник и проекты Jira/Git. До отложенной серии фиксируются критерии и независимо известные последствия. Нет постоянного инженера и разметчика; человеческие минуты поддержки измеряются отдельно. Цена, срок и экономия не установлены.</a:t>
-            </a:r>
-          </a:p>
-          <a:p xmlns:a="http://schemas.openxmlformats.org/drawingml/2006/main">
-            <a:r>
-              <a:t/>
-            </a:r>
-          </a:p>
-          <a:p xmlns:a="http://schemas.openxmlformats.org/drawingml/2006/main">
-            <a:r>
-              <a:t>Источники:</a:t>
-            </a:r>
-          </a:p>
-          <a:p xmlns:a="http://schemas.openxmlformats.org/drawingml/2006/main">
-            <a:r>
-              <a:t>docs/product/pilot/OFFER.md</a:t>
-            </a:r>
-          </a:p>
-          <a:p xmlns:a="http://schemas.openxmlformats.org/drawingml/2006/main">
-            <a:r>
-              <a:t>docs/product/pilot/PROTOCOL.md</a:t>
-            </a:r>
-          </a:p>
-          <a:p xmlns:a="http://schemas.openxmlformats.org/drawingml/2006/main">
-            <a:r>
-              <a:t>docs/product/pilot/ECONOMICS.md</a:t>
+              <a:t>Пилот на одном HTTP/Python API и его потребителях, 2–5 репозиториях GitHub и проекте Jira, если он есть. Права: чтение кода и PR, запись только своих комментариев. До прогона согласуем критерии и правила остановки. Человеческие минуты считаем отдельно от машинного времени. Цена, срок и объём пока предложение с допущениями.</a:t>
             </a:r>
           </a:p>
         </p:txBody>
@@ -4939,7 +4754,7 @@
                 <a:ea typeface="Arial"/>
                 <a:cs typeface="Arial"/>
               </a:rPr>
-              <a:t>Концепция автономного MVP · 24 октября 2026</a:t>
+              <a:t>Закрытый технический пилот · 29 октября 2026</a:t>
             </a:r>
           </a:p>
         </p:txBody>
@@ -8723,7 +8538,7 @@
                 <a:ea typeface="Arial"/>
                 <a:cs typeface="Arial"/>
               </a:rPr>
-              <a:t>Трассы и журналы</a:t>
+              <a:t>Журналы доступа</a:t>
             </a:r>
           </a:p>
         </p:txBody>
@@ -11593,7 +11408,7 @@
                 <a:ea typeface="Arial"/>
                 <a:cs typeface="Arial"/>
               </a:rPr>
-              <a:t>Готовый образ</a:t>
+              <a:t>Релиз и systemd</a:t>
             </a:r>
           </a:p>
           <a:p xmlns:a="http://schemas.openxmlformats.org/drawingml/2006/main">
@@ -11616,7 +11431,7 @@
                 <a:ea typeface="Arial"/>
                 <a:cs typeface="Arial"/>
               </a:rPr>
-              <a:t>Linux-ВМ</a:t>
+              <a:t>на Linux-ВМ</a:t>
             </a:r>
           </a:p>
         </p:txBody>
@@ -12114,7 +11929,7 @@
                 <a:ea typeface="Arial"/>
                 <a:cs typeface="Arial"/>
               </a:rPr>
-              <a:t>Код, вызовы</a:t>
+              <a:t>GitHub App, Jira</a:t>
             </a:r>
           </a:p>
           <a:p xmlns:a="http://schemas.openxmlformats.org/drawingml/2006/main">
@@ -12137,7 +11952,7 @@
                 <a:ea typeface="Arial"/>
                 <a:cs typeface="Arial"/>
               </a:rPr>
-              <a:t>Jira и Git</a:t>
+              <a:t>HTTP/Python-код</a:t>
             </a:r>
           </a:p>
         </p:txBody>
@@ -12635,7 +12450,7 @@
                 <a:ea typeface="Arial"/>
                 <a:cs typeface="Arial"/>
               </a:rPr>
-              <a:t>Модель, доступы</a:t>
+              <a:t>Доступы и лимиты</a:t>
             </a:r>
           </a:p>
           <a:p xmlns:a="http://schemas.openxmlformats.org/drawingml/2006/main">
@@ -12658,7 +12473,7 @@
                 <a:ea typeface="Arial"/>
                 <a:cs typeface="Arial"/>
               </a:rPr>
-              <a:t>конституция, лимиты</a:t>
+              <a:t>модель выключена</a:t>
             </a:r>
           </a:p>
         </p:txBody>
@@ -13358,7 +13173,7 @@
                 <a:ea typeface="Arial"/>
                 <a:cs typeface="Arial"/>
               </a:rPr>
-              <a:t>Сбои, актуальность и пределы работы видны в результате.</a:t>
+              <a:t>Сбои, свежесть и пределы анализа видны в комментарии.</a:t>
             </a:r>
           </a:p>
         </p:txBody>
@@ -13543,7 +13358,7 @@
                 <a:ea typeface="Arial"/>
                 <a:cs typeface="Arial"/>
               </a:rPr>
-              <a:t>Что работает сейчас и что входит в MVP</a:t>
+              <a:t>Что проверено и что ещё нет</a:t>
             </a:r>
           </a:p>
         </p:txBody>
@@ -13855,7 +13670,7 @@
                 <a:ea typeface="Arial"/>
                 <a:cs typeface="Arial"/>
               </a:rPr>
-              <a:t>Работает в прототипе</a:t>
+              <a:t>Проверено локально и в CI</a:t>
             </a:r>
           </a:p>
         </p:txBody>
@@ -14011,7 +13826,7 @@
                 <a:ea typeface="Arial"/>
                 <a:cs typeface="Arial"/>
               </a:rPr>
-              <a:t>Узкий статический анализ API</a:t>
+              <a:t>Jira и PR → один комментарий</a:t>
             </a:r>
           </a:p>
           <a:p xmlns:a="http://schemas.openxmlformats.org/drawingml/2006/main">
@@ -14034,7 +13849,7 @@
                 <a:ea typeface="Arial"/>
                 <a:cs typeface="Arial"/>
               </a:rPr>
-              <a:t>Проверяемые ссылки на исходники</a:t>
+              <a:t>Основание: репо@коммит:строка</a:t>
             </a:r>
           </a:p>
           <a:p xmlns:a="http://schemas.openxmlformats.org/drawingml/2006/main">
@@ -14057,7 +13872,7 @@
                 <a:ea typeface="Arial"/>
                 <a:cs typeface="Arial"/>
               </a:rPr>
-              <a:t>История результатов</a:t>
+              <a:t>Установка и откат релиза (CI systemd)</a:t>
             </a:r>
           </a:p>
           <a:p xmlns:a="http://schemas.openxmlformats.org/drawingml/2006/main">
@@ -14080,7 +13895,7 @@
                 <a:ea typeface="Arial"/>
                 <a:cs typeface="Arial"/>
               </a:rPr>
-              <a:t>Синтетический сценарий демо</a:t>
+              <a:t>Показ: изменение → исправление</a:t>
             </a:r>
           </a:p>
         </p:txBody>
@@ -14236,7 +14051,7 @@
                 <a:ea typeface="Arial"/>
                 <a:cs typeface="Arial"/>
               </a:rPr>
-              <a:t>Следующий автономный выпуск</a:t>
+              <a:t>Ещё не проверено</a:t>
             </a:r>
           </a:p>
         </p:txBody>
@@ -14392,7 +14207,7 @@
                 <a:ea typeface="Arial"/>
                 <a:cs typeface="Arial"/>
               </a:rPr>
-              <a:t>Jira и PR без ручного запуска</a:t>
+              <a:t>Настоящие GitHub App и Jira (LIVE)</a:t>
             </a:r>
           </a:p>
           <a:p xmlns:a="http://schemas.openxmlformats.org/drawingml/2006/main">
@@ -14415,7 +14230,7 @@
                 <a:ea typeface="Arial"/>
                 <a:cs typeface="Arial"/>
               </a:rPr>
-              <a:t>Обновляемый граф и данные о вызовах</a:t>
+              <a:t>Установка на ВМ Cloud.ru</a:t>
             </a:r>
           </a:p>
           <a:p xmlns:a="http://schemas.openxmlformats.org/drawingml/2006/main">
@@ -14438,7 +14253,7 @@
                 <a:ea typeface="Arial"/>
                 <a:cs typeface="Arial"/>
               </a:rPr>
-              <a:t>Проверенная открытая модель</a:t>
+              <a:t>Незнакомый проект и польза команды</a:t>
             </a:r>
           </a:p>
           <a:p xmlns:a="http://schemas.openxmlformats.org/drawingml/2006/main">
@@ -14461,7 +14276,7 @@
                 <a:ea typeface="Arial"/>
                 <a:cs typeface="Arial"/>
               </a:rPr>
-              <a:t>Установка и восстановление из коробки</a:t>
+              <a:t>Модель: допуск не пройден, OFF</a:t>
             </a:r>
           </a:p>
         </p:txBody>
@@ -14647,7 +14462,7 @@
                 <a:ea typeface="Arial"/>
                 <a:cs typeface="Arial"/>
               </a:rPr>
-              <a:t>Преимущество, экономия и работа на коде клиента ещё требуют проверки.</a:t>
+              <a:t>Профиль пилота: HTTP API на Python. Экономия и преимущество не измерены.</a:t>
             </a:r>
           </a:p>
         </p:txBody>
@@ -14832,7 +14647,7 @@
                 <a:ea typeface="Arial"/>
                 <a:cs typeface="Arial"/>
               </a:rPr>
-              <a:t>Первое подключение: один сквозной сценарий</a:t>
+              <a:t>Закрытый пилот: один сквозной сценарий</a:t>
             </a:r>
           </a:p>
         </p:txBody>
@@ -15300,7 +15115,7 @@
                 <a:ea typeface="Arial"/>
                 <a:cs typeface="Arial"/>
               </a:rPr>
-              <a:t>Один API и его потребители</a:t>
+              <a:t>Один HTTP/Python API и потребители</a:t>
             </a:r>
           </a:p>
           <a:p xmlns:a="http://schemas.openxmlformats.org/drawingml/2006/main">
@@ -15323,7 +15138,7 @@
                 <a:ea typeface="Arial"/>
                 <a:cs typeface="Arial"/>
               </a:rPr>
-              <a:t>Код + источник наблюдаемых вызовов</a:t>
+              <a:t>2–5 репозиториев GitHub</a:t>
             </a:r>
           </a:p>
           <a:p xmlns:a="http://schemas.openxmlformats.org/drawingml/2006/main">
@@ -15346,7 +15161,7 @@
                 <a:ea typeface="Arial"/>
                 <a:cs typeface="Arial"/>
               </a:rPr>
-              <a:t>Проекты Jira и Git</a:t>
+              <a:t>Проект Jira, если он есть</a:t>
             </a:r>
           </a:p>
           <a:p xmlns:a="http://schemas.openxmlformats.org/drawingml/2006/main">
@@ -15369,7 +15184,7 @@
                 <a:ea typeface="Arial"/>
                 <a:cs typeface="Arial"/>
               </a:rPr>
-              <a:t>Подключённая открытая модель</a:t>
+              <a:t>Права: чтение и свой комментарий</a:t>
             </a:r>
           </a:p>
         </p:txBody>
@@ -15681,7 +15496,7 @@
                 <a:ea typeface="Arial"/>
                 <a:cs typeface="Arial"/>
               </a:rPr>
-              <a:t>Время до полезного инсайта</a:t>
+              <a:t>Время до полезного вывода</a:t>
             </a:r>
           </a:p>
           <a:p xmlns:a="http://schemas.openxmlformats.org/drawingml/2006/main">
@@ -15704,7 +15519,7 @@
                 <a:ea typeface="Arial"/>
                 <a:cs typeface="Arial"/>
               </a:rPr>
-              <a:t>Основания, пропуски и ложные сигналы</a:t>
+              <a:t>Пропуски и ложные сигналы</a:t>
             </a:r>
           </a:p>
           <a:p xmlns:a="http://schemas.openxmlformats.org/drawingml/2006/main">
@@ -15727,7 +15542,7 @@
                 <a:ea typeface="Arial"/>
                 <a:cs typeface="Arial"/>
               </a:rPr>
-              <a:t>Ручные минуты поддержки</a:t>
+              <a:t>Ручные минуты подключения</a:t>
             </a:r>
           </a:p>
           <a:p xmlns:a="http://schemas.openxmlformats.org/drawingml/2006/main">
@@ -15750,7 +15565,7 @@
                 <a:ea typeface="Arial"/>
                 <a:cs typeface="Arial"/>
               </a:rPr>
-              <a:t>Стоимость полезного результата</a:t>
+              <a:t>Сравнение с обычным процессом</a:t>
             </a:r>
           </a:p>
         </p:txBody>
@@ -15906,7 +15721,7 @@
                 <a:ea typeface="Arial"/>
                 <a:cs typeface="Arial"/>
               </a:rPr>
-              <a:t>Цель — полезный ответ раньше,</a:t>
+              <a:t>Условия пилота: предложение с допущениями,</a:t>
             </a:r>
           </a:p>
           <a:p xmlns:a="http://schemas.openxmlformats.org/drawingml/2006/main">
@@ -15929,7 +15744,7 @@
                 <a:ea typeface="Arial"/>
                 <a:cs typeface="Arial"/>
               </a:rPr>
-              <a:t>с минимальным участием команды.</a:t>
+              <a:t>а не утверждённая сделка.</a:t>
             </a:r>
           </a:p>
         </p:txBody>

</xml_diff>